<commit_message>
add dsai-competency skill, tidy wording and doc properties
Co-Authored-By: Claude Opus 5 <noreply@anthropic.com>
</commit_message>
<xml_diff>
--- a/competency-map/SEA DSAI Update on competency maps (Final).pptx
+++ b/competency-map/SEA DSAI Update on competency maps (Final).pptx
@@ -206,10 +206,10 @@
 
 <file path=ppt/commentAuthors.xml><?xml version="1.0" encoding="utf-8"?>
 <p:cmAuthorLst xmlns:a="http://schemas.openxmlformats.org/drawingml/2006/main" xmlns:r="http://schemas.openxmlformats.org/officeDocument/2006/relationships" xmlns:p="http://schemas.openxmlformats.org/presentationml/2006/main">
-  <p:cmAuthor id="1" name="Avery Khoo" initials="Av" lastIdx="1" clrIdx="0">
+  <p:cmAuthor id="1" name="Author" initials="A" lastIdx="1" clrIdx="0">
     <p:extLst>
       <p:ext uri="{19B8F6BF-5375-455C-9EA6-DF929625EA0E}">
-        <p15:presenceInfo xmlns:p15="http://schemas.microsoft.com/office/powerpoint/2012/main" userId="Avery Khoo" providerId="None"/>
+        <p15:presenceInfo xmlns:p15="http://schemas.microsoft.com/office/powerpoint/2012/main" userId="Author" providerId="None"/>
       </p:ext>
     </p:extLst>
   </p:cmAuthor>
@@ -2856,7 +2856,7 @@
           <a:p>
             <a:r>
               <a:rPr lang="en-US" dirty="0"/>
-              <a:t>Ask Jianzhi for slide template</a:t>
+              <a:t>Ask Avery for slide template</a:t>
             </a:r>
             <a:br>
               <a:rPr lang="en-US" dirty="0"/>
@@ -21173,209 +21173,4 @@
     </a:ext>
   </a:extLst>
 </a:theme>
-</file>
-
-<file path=customXml/item1.xml><?xml version="1.0" encoding="utf-8"?>
-<p:properties xmlns:p="http://schemas.microsoft.com/office/2006/metadata/properties" xmlns:xsi="http://www.w3.org/2001/XMLSchema-instance" xmlns:pc="http://schemas.microsoft.com/office/infopath/2007/PartnerControls">
-  <documentManagement/>
-</p:properties>
-</file>
-
-<file path=customXml/item2.xml><?xml version="1.0" encoding="utf-8"?>
-<?mso-contentType ?>
-<FormTemplates xmlns="http://schemas.microsoft.com/sharepoint/v3/contenttype/forms">
-  <Display>DocumentLibraryForm</Display>
-  <Edit>DocumentLibraryForm</Edit>
-  <New>DocumentLibraryForm</New>
-</FormTemplates>
-</file>
-
-<file path=customXml/item3.xml><?xml version="1.0" encoding="utf-8"?>
-<ct:contentTypeSchema xmlns:ct="http://schemas.microsoft.com/office/2006/metadata/contentType" xmlns:ma="http://schemas.microsoft.com/office/2006/metadata/properties/metaAttributes" ct:_="" ma:_="" ma:contentTypeName="Document" ma:contentTypeID="0x0101000E943A1FDA6A3043A73B5E2B07F1DAF9" ma:contentTypeVersion="2" ma:contentTypeDescription="Create a new document." ma:contentTypeScope="" ma:versionID="7e4dd936dce5acd3f69957d751a16843">
-  <xsd:schema xmlns:xsd="http://www.w3.org/2001/XMLSchema" xmlns:xs="http://www.w3.org/2001/XMLSchema" xmlns:p="http://schemas.microsoft.com/office/2006/metadata/properties" xmlns:ns2="9844aafb-f82d-4239-a15f-d1a798f20533" targetNamespace="http://schemas.microsoft.com/office/2006/metadata/properties" ma:root="true" ma:fieldsID="6511139824e80a9fa5976a859d6c5e78" ns2:_="">
-    <xsd:import namespace="9844aafb-f82d-4239-a15f-d1a798f20533"/>
-    <xsd:element name="properties">
-      <xsd:complexType>
-        <xsd:sequence>
-          <xsd:element name="documentManagement">
-            <xsd:complexType>
-              <xsd:all>
-                <xsd:element ref="ns2:SharedWithUsers" minOccurs="0"/>
-                <xsd:element ref="ns2:SharedWithDetails" minOccurs="0"/>
-              </xsd:all>
-            </xsd:complexType>
-          </xsd:element>
-        </xsd:sequence>
-      </xsd:complexType>
-    </xsd:element>
-  </xsd:schema>
-  <xsd:schema xmlns:xsd="http://www.w3.org/2001/XMLSchema" xmlns:xs="http://www.w3.org/2001/XMLSchema" xmlns:dms="http://schemas.microsoft.com/office/2006/documentManagement/types" xmlns:pc="http://schemas.microsoft.com/office/infopath/2007/PartnerControls" targetNamespace="9844aafb-f82d-4239-a15f-d1a798f20533" elementFormDefault="qualified">
-    <xsd:import namespace="http://schemas.microsoft.com/office/2006/documentManagement/types"/>
-    <xsd:import namespace="http://schemas.microsoft.com/office/infopath/2007/PartnerControls"/>
-    <xsd:element name="SharedWithUsers" ma:index="8" nillable="true" ma:displayName="Shared With" ma:internalName="SharedWithUsers" ma:readOnly="true">
-      <xsd:complexType>
-        <xsd:complexContent>
-          <xsd:extension base="dms:UserMulti">
-            <xsd:sequence>
-              <xsd:element name="UserInfo" minOccurs="0" maxOccurs="unbounded">
-                <xsd:complexType>
-                  <xsd:sequence>
-                    <xsd:element name="DisplayName" type="xsd:string" minOccurs="0"/>
-                    <xsd:element name="AccountId" type="dms:UserId" minOccurs="0" nillable="true"/>
-                    <xsd:element name="AccountType" type="xsd:string" minOccurs="0"/>
-                  </xsd:sequence>
-                </xsd:complexType>
-              </xsd:element>
-            </xsd:sequence>
-          </xsd:extension>
-        </xsd:complexContent>
-      </xsd:complexType>
-    </xsd:element>
-    <xsd:element name="SharedWithDetails" ma:index="9" nillable="true" ma:displayName="Shared With Details" ma:internalName="SharedWithDetails" ma:readOnly="true">
-      <xsd:simpleType>
-        <xsd:restriction base="dms:Note">
-          <xsd:maxLength value="255"/>
-        </xsd:restriction>
-      </xsd:simpleType>
-    </xsd:element>
-  </xsd:schema>
-  <xsd:schema xmlns="http://schemas.openxmlformats.org/package/2006/metadata/core-properties" xmlns:xsd="http://www.w3.org/2001/XMLSchema" xmlns:xsi="http://www.w3.org/2001/XMLSchema-instance" xmlns:dc="http://purl.org/dc/elements/1.1/" xmlns:dcterms="http://purl.org/dc/terms/" xmlns:odoc="http://schemas.microsoft.com/internal/obd" targetNamespace="http://schemas.openxmlformats.org/package/2006/metadata/core-properties" elementFormDefault="qualified" attributeFormDefault="unqualified" blockDefault="#all">
-    <xsd:import namespace="http://purl.org/dc/elements/1.1/" schemaLocation="http://dublincore.org/schemas/xmls/qdc/2003/04/02/dc.xsd"/>
-    <xsd:import namespace="http://purl.org/dc/terms/" schemaLocation="http://dublincore.org/schemas/xmls/qdc/2003/04/02/dcterms.xsd"/>
-    <xsd:element name="coreProperties" type="CT_coreProperties"/>
-    <xsd:complexType name="CT_coreProperties">
-      <xsd:all>
-        <xsd:element ref="dc:creator" minOccurs="0" maxOccurs="1"/>
-        <xsd:element ref="dcterms:created" minOccurs="0" maxOccurs="1"/>
-        <xsd:element ref="dc:identifier" minOccurs="0" maxOccurs="1"/>
-        <xsd:element name="contentType" minOccurs="0" maxOccurs="1" type="xsd:string" ma:index="0" ma:displayName="Content Type"/>
-        <xsd:element ref="dc:title" minOccurs="0" maxOccurs="1" ma:index="4" ma:displayName="Title"/>
-        <xsd:element ref="dc:subject" minOccurs="0" maxOccurs="1"/>
-        <xsd:element ref="dc:description" minOccurs="0" maxOccurs="1"/>
-        <xsd:element name="keywords" minOccurs="0" maxOccurs="1" type="xsd:string"/>
-        <xsd:element ref="dc:language" minOccurs="0" maxOccurs="1"/>
-        <xsd:element name="category" minOccurs="0" maxOccurs="1" type="xsd:string"/>
-        <xsd:element name="version" minOccurs="0" maxOccurs="1" type="xsd:string"/>
-        <xsd:element name="revision" minOccurs="0" maxOccurs="1" type="xsd:string">
-          <xsd:annotation>
-            <xsd:documentation>
-                        This value indicates the number of saves or revisions. The application is responsible for updating this value after each revision.
-                    </xsd:documentation>
-          </xsd:annotation>
-        </xsd:element>
-        <xsd:element name="lastModifiedBy" minOccurs="0" maxOccurs="1" type="xsd:string"/>
-        <xsd:element ref="dcterms:modified" minOccurs="0" maxOccurs="1"/>
-        <xsd:element name="contentStatus" minOccurs="0" maxOccurs="1" type="xsd:string"/>
-      </xsd:all>
-    </xsd:complexType>
-  </xsd:schema>
-  <xs:schema xmlns:pc="http://schemas.microsoft.com/office/infopath/2007/PartnerControls" xmlns:xs="http://www.w3.org/2001/XMLSchema" targetNamespace="http://schemas.microsoft.com/office/infopath/2007/PartnerControls" elementFormDefault="qualified" attributeFormDefault="unqualified">
-    <xs:element name="Person">
-      <xs:complexType>
-        <xs:sequence>
-          <xs:element ref="pc:DisplayName" minOccurs="0"/>
-          <xs:element ref="pc:AccountId" minOccurs="0"/>
-          <xs:element ref="pc:AccountType" minOccurs="0"/>
-        </xs:sequence>
-      </xs:complexType>
-    </xs:element>
-    <xs:element name="DisplayName" type="xs:string"/>
-    <xs:element name="AccountId" type="xs:string"/>
-    <xs:element name="AccountType" type="xs:string"/>
-    <xs:element name="BDCAssociatedEntity">
-      <xs:complexType>
-        <xs:sequence>
-          <xs:element ref="pc:BDCEntity" minOccurs="0" maxOccurs="unbounded"/>
-        </xs:sequence>
-        <xs:attribute ref="pc:EntityNamespace"/>
-        <xs:attribute ref="pc:EntityName"/>
-        <xs:attribute ref="pc:SystemInstanceName"/>
-        <xs:attribute ref="pc:AssociationName"/>
-      </xs:complexType>
-    </xs:element>
-    <xs:attribute name="EntityNamespace" type="xs:string"/>
-    <xs:attribute name="EntityName" type="xs:string"/>
-    <xs:attribute name="SystemInstanceName" type="xs:string"/>
-    <xs:attribute name="AssociationName" type="xs:string"/>
-    <xs:element name="BDCEntity">
-      <xs:complexType>
-        <xs:sequence>
-          <xs:element ref="pc:EntityDisplayName" minOccurs="0"/>
-          <xs:element ref="pc:EntityInstanceReference" minOccurs="0"/>
-          <xs:element ref="pc:EntityId1" minOccurs="0"/>
-          <xs:element ref="pc:EntityId2" minOccurs="0"/>
-          <xs:element ref="pc:EntityId3" minOccurs="0"/>
-          <xs:element ref="pc:EntityId4" minOccurs="0"/>
-          <xs:element ref="pc:EntityId5" minOccurs="0"/>
-        </xs:sequence>
-      </xs:complexType>
-    </xs:element>
-    <xs:element name="EntityDisplayName" type="xs:string"/>
-    <xs:element name="EntityInstanceReference" type="xs:string"/>
-    <xs:element name="EntityId1" type="xs:string"/>
-    <xs:element name="EntityId2" type="xs:string"/>
-    <xs:element name="EntityId3" type="xs:string"/>
-    <xs:element name="EntityId4" type="xs:string"/>
-    <xs:element name="EntityId5" type="xs:string"/>
-    <xs:element name="Terms">
-      <xs:complexType>
-        <xs:sequence>
-          <xs:element ref="pc:TermInfo" minOccurs="0" maxOccurs="unbounded"/>
-        </xs:sequence>
-      </xs:complexType>
-    </xs:element>
-    <xs:element name="TermInfo">
-      <xs:complexType>
-        <xs:sequence>
-          <xs:element ref="pc:TermName" minOccurs="0"/>
-          <xs:element ref="pc:TermId" minOccurs="0"/>
-        </xs:sequence>
-      </xs:complexType>
-    </xs:element>
-    <xs:element name="TermName" type="xs:string"/>
-    <xs:element name="TermId" type="xs:string"/>
-  </xs:schema>
-</ct:contentTypeSchema>
-</file>
-
-<file path=customXml/itemProps1.xml><?xml version="1.0" encoding="utf-8"?>
-<ds:datastoreItem xmlns:ds="http://schemas.openxmlformats.org/officeDocument/2006/customXml" ds:itemID="{28EB2BC4-8C03-4534-BCE7-3CA307963B3B}">
-  <ds:schemaRefs>
-    <ds:schemaRef ds:uri="http://schemas.microsoft.com/office/infopath/2007/PartnerControls"/>
-    <ds:schemaRef ds:uri="http://purl.org/dc/dcmitype/"/>
-    <ds:schemaRef ds:uri="http://schemas.openxmlformats.org/package/2006/metadata/core-properties"/>
-    <ds:schemaRef ds:uri="http://schemas.microsoft.com/office/2006/documentManagement/types"/>
-    <ds:schemaRef ds:uri="http://purl.org/dc/elements/1.1/"/>
-    <ds:schemaRef ds:uri="http://www.w3.org/XML/1998/namespace"/>
-    <ds:schemaRef ds:uri="http://purl.org/dc/terms/"/>
-    <ds:schemaRef ds:uri="9844aafb-f82d-4239-a15f-d1a798f20533"/>
-    <ds:schemaRef ds:uri="http://schemas.microsoft.com/office/2006/metadata/properties"/>
-  </ds:schemaRefs>
-</ds:datastoreItem>
-</file>
-
-<file path=customXml/itemProps2.xml><?xml version="1.0" encoding="utf-8"?>
-<ds:datastoreItem xmlns:ds="http://schemas.openxmlformats.org/officeDocument/2006/customXml" ds:itemID="{A231418A-1B93-4088-BC02-04007F714E64}">
-  <ds:schemaRefs>
-    <ds:schemaRef ds:uri="http://schemas.microsoft.com/sharepoint/v3/contenttype/forms"/>
-  </ds:schemaRefs>
-</ds:datastoreItem>
-</file>
-
-<file path=customXml/itemProps3.xml><?xml version="1.0" encoding="utf-8"?>
-<ds:datastoreItem xmlns:ds="http://schemas.openxmlformats.org/officeDocument/2006/customXml" ds:itemID="{A3B6C287-14C1-4356-A883-8ED85CFD2F3F}">
-  <ds:schemaRefs>
-    <ds:schemaRef ds:uri="http://schemas.microsoft.com/office/2006/metadata/contentType"/>
-    <ds:schemaRef ds:uri="http://schemas.microsoft.com/office/2006/metadata/properties/metaAttributes"/>
-    <ds:schemaRef ds:uri="http://www.w3.org/2001/XMLSchema"/>
-    <ds:schemaRef ds:uri="http://schemas.microsoft.com/office/2006/metadata/properties"/>
-    <ds:schemaRef ds:uri="9844aafb-f82d-4239-a15f-d1a798f20533"/>
-    <ds:schemaRef ds:uri="http://schemas.microsoft.com/office/2006/documentManagement/types"/>
-    <ds:schemaRef ds:uri="http://schemas.microsoft.com/office/infopath/2007/PartnerControls"/>
-    <ds:schemaRef ds:uri="http://schemas.openxmlformats.org/package/2006/metadata/core-properties"/>
-    <ds:schemaRef ds:uri="http://purl.org/dc/elements/1.1/"/>
-    <ds:schemaRef ds:uri="http://purl.org/dc/terms/"/>
-    <ds:schemaRef ds:uri="http://schemas.microsoft.com/internal/obd"/>
-  </ds:schemaRefs>
-</ds:datastoreItem>
 </file>
</xml_diff>